<commit_message>
Reduce quiz to 3 questions
Co-Authored-By: Claude Sonnet 5.5 <noreply@anthropic.com>
Claude-Session: https://claude.ai/code/session_013pees9qpBAQFAX4Q8ZJikM
</commit_message>
<xml_diff>
--- a/Ekonomicheskie_krizisy_RU_viktorina.pptx
+++ b/Ekonomicheskie_krizisy_RU_viktorina.pptx
@@ -14,9 +14,6 @@
     <p:sldId id="262" r:id="rId13"/>
     <p:sldId id="263" r:id="rId14"/>
     <p:sldId id="264" r:id="rId15"/>
-    <p:sldId id="265" r:id="rId16"/>
-    <p:sldId id="266" r:id="rId17"/>
-    <p:sldId id="267" r:id="rId18"/>
   </p:sldIdLst>
   <p:notesMasterIdLst>
     <p:notesMasterId r:id="rId7"/>
@@ -579,216 +576,6 @@
 </p:notes>
 </file>
 
-<file path=ppt/notesSlides/notesSlide10.xml><?xml version="1.0" encoding="utf-8"?>
-<p:notes xmlns:a="http://schemas.openxmlformats.org/drawingml/2006/main" xmlns:p="http://schemas.openxmlformats.org/presentationml/2006/main" xmlns:r="http://schemas.openxmlformats.org/officeDocument/2006/relationships">
-  <p:cSld>
-    <p:spTree>
-      <p:nvGrpSpPr>
-        <p:cNvPr id="1" name=""/>
-        <p:cNvGrpSpPr/>
-        <p:nvPr/>
-      </p:nvGrpSpPr>
-      <p:grpSpPr>
-        <a:xfrm>
-          <a:off x="0" y="0"/>
-          <a:ext cx="0" cy="0"/>
-          <a:chOff x="0" y="0"/>
-          <a:chExt cx="0" cy="0"/>
-        </a:xfrm>
-      </p:grpSpPr>
-      <p:sp>
-        <p:nvSpPr>
-          <p:cNvPr id="2" name="Slide Image Placeholder 1"/>
-          <p:cNvSpPr>
-            <a:spLocks noGrp="1"/>
-          </p:cNvSpPr>
-          <p:nvPr>
-            <p:ph type="sldImg" idx="2"/>
-          </p:nvPr>
-        </p:nvSpPr>
-        <p:spPr/>
-      </p:sp>
-      <p:sp>
-        <p:nvSpPr>
-          <p:cNvPr id="3" name="Notes Placeholder 2"/>
-          <p:cNvSpPr>
-            <a:spLocks noGrp="1"/>
-          </p:cNvSpPr>
-          <p:nvPr>
-            <p:ph type="body" idx="3" sz="quarter"/>
-          </p:nvPr>
-        </p:nvSpPr>
-        <p:spPr/>
-        <p:txBody>
-          <a:bodyPr/>
-          <a:lstStyle/>
-          <a:p>
-            <a:r>
-              <a:t>Вопрос 5. Как распространялся кризис 1900–1902 годов? Правильный ответ: США → Англия → Европа.</a:t>
-            </a:r>
-          </a:p>
-        </p:txBody>
-      </p:sp>
-      <p:sp>
-        <p:nvSpPr>
-          <p:cNvPr id="4" name="Slide Number Placeholder 3"/>
-          <p:cNvSpPr>
-            <a:spLocks noGrp="1"/>
-          </p:cNvSpPr>
-          <p:nvPr>
-            <p:ph type="sldNum" idx="5" sz="quarter"/>
-          </p:nvPr>
-        </p:nvSpPr>
-        <p:spPr/>
-      </p:sp>
-    </p:spTree>
-  </p:cSld>
-  <p:clrMapOvr>
-    <a:masterClrMapping/>
-  </p:clrMapOvr>
-</p:notes>
-</file>
-
-<file path=ppt/notesSlides/notesSlide11.xml><?xml version="1.0" encoding="utf-8"?>
-<p:notes xmlns:a="http://schemas.openxmlformats.org/drawingml/2006/main" xmlns:p="http://schemas.openxmlformats.org/presentationml/2006/main" xmlns:r="http://schemas.openxmlformats.org/officeDocument/2006/relationships">
-  <p:cSld>
-    <p:spTree>
-      <p:nvGrpSpPr>
-        <p:cNvPr id="1" name=""/>
-        <p:cNvGrpSpPr/>
-        <p:nvPr/>
-      </p:nvGrpSpPr>
-      <p:grpSpPr>
-        <a:xfrm>
-          <a:off x="0" y="0"/>
-          <a:ext cx="0" cy="0"/>
-          <a:chOff x="0" y="0"/>
-          <a:chExt cx="0" cy="0"/>
-        </a:xfrm>
-      </p:grpSpPr>
-      <p:sp>
-        <p:nvSpPr>
-          <p:cNvPr id="2" name="Slide Image Placeholder 1"/>
-          <p:cNvSpPr>
-            <a:spLocks noGrp="1"/>
-          </p:cNvSpPr>
-          <p:nvPr>
-            <p:ph type="sldImg" idx="2"/>
-          </p:nvPr>
-        </p:nvSpPr>
-        <p:spPr/>
-      </p:sp>
-      <p:sp>
-        <p:nvSpPr>
-          <p:cNvPr id="3" name="Notes Placeholder 2"/>
-          <p:cNvSpPr>
-            <a:spLocks noGrp="1"/>
-          </p:cNvSpPr>
-          <p:nvPr>
-            <p:ph type="body" idx="3" sz="quarter"/>
-          </p:nvPr>
-        </p:nvSpPr>
-        <p:spPr/>
-        <p:txBody>
-          <a:bodyPr/>
-          <a:lstStyle/>
-          <a:p>
-            <a:r>
-              <a:t>Вопрос 6. Как менялись цены, когда кризис углублялся? Правильный ответ: Постепенно падали.</a:t>
-            </a:r>
-          </a:p>
-        </p:txBody>
-      </p:sp>
-      <p:sp>
-        <p:nvSpPr>
-          <p:cNvPr id="4" name="Slide Number Placeholder 3"/>
-          <p:cNvSpPr>
-            <a:spLocks noGrp="1"/>
-          </p:cNvSpPr>
-          <p:nvPr>
-            <p:ph type="sldNum" idx="5" sz="quarter"/>
-          </p:nvPr>
-        </p:nvSpPr>
-        <p:spPr/>
-      </p:sp>
-    </p:spTree>
-  </p:cSld>
-  <p:clrMapOvr>
-    <a:masterClrMapping/>
-  </p:clrMapOvr>
-</p:notes>
-</file>
-
-<file path=ppt/notesSlides/notesSlide12.xml><?xml version="1.0" encoding="utf-8"?>
-<p:notes xmlns:a="http://schemas.openxmlformats.org/drawingml/2006/main" xmlns:p="http://schemas.openxmlformats.org/presentationml/2006/main" xmlns:r="http://schemas.openxmlformats.org/officeDocument/2006/relationships">
-  <p:cSld>
-    <p:spTree>
-      <p:nvGrpSpPr>
-        <p:cNvPr id="1" name=""/>
-        <p:cNvGrpSpPr/>
-        <p:nvPr/>
-      </p:nvGrpSpPr>
-      <p:grpSpPr>
-        <a:xfrm>
-          <a:off x="0" y="0"/>
-          <a:ext cx="0" cy="0"/>
-          <a:chOff x="0" y="0"/>
-          <a:chExt cx="0" cy="0"/>
-        </a:xfrm>
-      </p:grpSpPr>
-      <p:sp>
-        <p:nvSpPr>
-          <p:cNvPr id="2" name="Slide Image Placeholder 1"/>
-          <p:cNvSpPr>
-            <a:spLocks noGrp="1"/>
-          </p:cNvSpPr>
-          <p:nvPr>
-            <p:ph type="sldImg" idx="2"/>
-          </p:nvPr>
-        </p:nvSpPr>
-        <p:spPr/>
-      </p:sp>
-      <p:sp>
-        <p:nvSpPr>
-          <p:cNvPr id="3" name="Notes Placeholder 2"/>
-          <p:cNvSpPr>
-            <a:spLocks noGrp="1"/>
-          </p:cNvSpPr>
-          <p:nvPr>
-            <p:ph type="body" idx="3" sz="quarter"/>
-          </p:nvPr>
-        </p:nvSpPr>
-        <p:spPr/>
-        <p:txBody>
-          <a:bodyPr/>
-          <a:lstStyle/>
-          <a:p>
-            <a:r>
-              <a:t>Подведите итоги: сколько ответов оказалось верными.</a:t>
-            </a:r>
-          </a:p>
-        </p:txBody>
-      </p:sp>
-      <p:sp>
-        <p:nvSpPr>
-          <p:cNvPr id="4" name="Slide Number Placeholder 3"/>
-          <p:cNvSpPr>
-            <a:spLocks noGrp="1"/>
-          </p:cNvSpPr>
-          <p:nvPr>
-            <p:ph type="sldNum" idx="5" sz="quarter"/>
-          </p:nvPr>
-        </p:nvSpPr>
-        <p:spPr/>
-      </p:sp>
-    </p:spTree>
-  </p:cSld>
-  <p:clrMapOvr>
-    <a:masterClrMapping/>
-  </p:clrMapOvr>
-</p:notes>
-</file>
-
 <file path=ppt/notesSlides/notesSlide2.xml><?xml version="1.0" encoding="utf-8"?>
 <p:notes xmlns:a="http://schemas.openxmlformats.org/drawingml/2006/main" xmlns:r="http://schemas.openxmlformats.org/officeDocument/2006/relationships" xmlns:p="http://schemas.openxmlformats.org/presentationml/2006/main">
   <p:cSld>
@@ -1232,7 +1019,7 @@
           <a:lstStyle/>
           <a:p>
             <a:r>
-              <a:t>Вопрос 2. Какие страны охватил кризис 1847 года? Правильный ответ: США, Англию, Францию и Германию.</a:t>
+              <a:t>Вопрос 2. Какую отрасль кризис 1900–1902 годов поразил первой? Правильный ответ: Металлургическую промышленность.</a:t>
             </a:r>
           </a:p>
         </p:txBody>
@@ -1302,7 +1089,7 @@
           <a:lstStyle/>
           <a:p>
             <a:r>
-              <a:t>Вопрос 3. Где одновременно начался самый тяжёлый кризис 1900–1902 годов? Правильный ответ: В России и США.</a:t>
+              <a:t>Вопрос 3. Как менялись цены, когда кризис углублялся? Правильный ответ: Постепенно падали.</a:t>
             </a:r>
           </a:p>
         </p:txBody>
@@ -1372,7 +1159,7 @@
           <a:lstStyle/>
           <a:p>
             <a:r>
-              <a:t>Вопрос 4. Какую отрасль кризис 1900–1902 годов поразил первой? Правильный ответ: Металлургическую промышленность.</a:t>
+              <a:t>Подведите итоги: сколько ответов оказалось верными.</a:t>
             </a:r>
           </a:p>
         </p:txBody>
@@ -1960,1247 +1747,6 @@
 </p:sld>
 </file>
 
-<file path=ppt/slides/slide10.xml><?xml version="1.0" encoding="utf-8"?>
-<p:sld xmlns:a="http://schemas.openxmlformats.org/drawingml/2006/main" xmlns:p="http://schemas.openxmlformats.org/presentationml/2006/main" xmlns:r="http://schemas.openxmlformats.org/officeDocument/2006/relationships">
-  <p:cSld>
-    <p:bg>
-      <p:bgPr>
-        <a:solidFill>
-          <a:srgbClr val="FFFFFF"/>
-        </a:solidFill>
-        <a:effectLst/>
-      </p:bgPr>
-    </p:bg>
-    <p:spTree>
-      <p:nvGrpSpPr>
-        <p:cNvPr id="1" name=""/>
-        <p:cNvGrpSpPr/>
-        <p:nvPr/>
-      </p:nvGrpSpPr>
-      <p:grpSpPr/>
-      <p:sp>
-        <p:nvSpPr>
-          <p:cNvPr id="2" name="Rectangle 1"/>
-          <p:cNvSpPr/>
-          <p:nvPr/>
-        </p:nvSpPr>
-        <p:spPr>
-          <a:xfrm>
-            <a:off x="731520" y="502920"/>
-            <a:ext cx="10698480" cy="274320"/>
-          </a:xfrm>
-          <a:prstGeom prst="rect">
-            <a:avLst/>
-          </a:prstGeom>
-          <a:noFill/>
-          <a:ln>
-            <a:noFill/>
-          </a:ln>
-          <a:effectLst/>
-        </p:spPr>
-        <p:style>
-          <a:lnRef idx="1">
-            <a:schemeClr val="accent1"/>
-          </a:lnRef>
-          <a:fillRef idx="3">
-            <a:schemeClr val="accent1"/>
-          </a:fillRef>
-          <a:effectRef idx="2">
-            <a:schemeClr val="accent1"/>
-          </a:effectRef>
-          <a:fontRef idx="minor">
-            <a:schemeClr val="lt1"/>
-          </a:fontRef>
-        </p:style>
-        <p:txBody>
-          <a:bodyPr rtlCol="0" anchor="ctr" wrap="square" lIns="0" rIns="0" tIns="0" bIns="0"/>
-          <a:lstStyle/>
-          <a:p>
-            <a:pPr algn="l"/>
-            <a:r>
-              <a:rPr sz="1200" b="1" spc="300">
-                <a:solidFill>
-                  <a:srgbClr val="A8432F"/>
-                </a:solidFill>
-                <a:latin typeface="Calibri"/>
-              </a:rPr>
-              <a:t>ВИКТОРИНА · 5 / 6</a:t>
-            </a:r>
-          </a:p>
-        </p:txBody>
-      </p:sp>
-      <p:sp>
-        <p:nvSpPr>
-          <p:cNvPr id="3" name="Rectangle 2"/>
-          <p:cNvSpPr/>
-          <p:nvPr/>
-        </p:nvSpPr>
-        <p:spPr>
-          <a:xfrm>
-            <a:off x="731520" y="850000"/>
-            <a:ext cx="10698480" cy="1200000"/>
-          </a:xfrm>
-          <a:prstGeom prst="rect">
-            <a:avLst/>
-          </a:prstGeom>
-          <a:noFill/>
-          <a:ln>
-            <a:noFill/>
-          </a:ln>
-          <a:effectLst/>
-        </p:spPr>
-        <p:style>
-          <a:lnRef idx="1">
-            <a:schemeClr val="accent1"/>
-          </a:lnRef>
-          <a:fillRef idx="3">
-            <a:schemeClr val="accent1"/>
-          </a:fillRef>
-          <a:effectRef idx="2">
-            <a:schemeClr val="accent1"/>
-          </a:effectRef>
-          <a:fontRef idx="minor">
-            <a:schemeClr val="lt1"/>
-          </a:fontRef>
-        </p:style>
-        <p:txBody>
-          <a:bodyPr rtlCol="0" anchor="t" wrap="square" lIns="0" rIns="0" tIns="0" bIns="0"/>
-          <a:lstStyle/>
-          <a:p>
-            <a:pPr algn="l"/>
-            <a:r>
-              <a:rPr sz="2800" b="1">
-                <a:solidFill>
-                  <a:srgbClr val="1B2A41"/>
-                </a:solidFill>
-                <a:latin typeface="Cambria"/>
-              </a:rPr>
-              <a:t>Как распространялся кризис 1900–1902 годов?</a:t>
-            </a:r>
-          </a:p>
-        </p:txBody>
-      </p:sp>
-      <p:sp>
-        <p:nvSpPr>
-          <p:cNvPr id="4" name="Rounded Rectangle 3"/>
-          <p:cNvSpPr/>
-          <p:nvPr/>
-        </p:nvSpPr>
-        <p:spPr>
-          <a:xfrm>
-            <a:off x="731520" y="2250000"/>
-            <a:ext cx="10698480" cy="1050000"/>
-          </a:xfrm>
-          <a:prstGeom prst="roundRect">
-            <a:avLst>
-              <a:gd name="adj" fmla="val 12000"/>
-            </a:avLst>
-          </a:prstGeom>
-          <a:solidFill>
-            <a:srgbClr val="F4EFE7"/>
-          </a:solidFill>
-          <a:ln>
-            <a:solidFill>
-              <a:srgbClr val="F4EFE7"/>
-            </a:solidFill>
-          </a:ln>
-          <a:effectLst/>
-        </p:spPr>
-        <p:style>
-          <a:lnRef idx="1">
-            <a:schemeClr val="accent1"/>
-          </a:lnRef>
-          <a:fillRef idx="3">
-            <a:schemeClr val="accent1"/>
-          </a:fillRef>
-          <a:effectRef idx="2">
-            <a:schemeClr val="accent1"/>
-          </a:effectRef>
-          <a:fontRef idx="minor">
-            <a:schemeClr val="lt1"/>
-          </a:fontRef>
-        </p:style>
-        <p:txBody>
-          <a:bodyPr rtlCol="0" anchor="ctr" wrap="square" lIns="228600" rIns="228600" tIns="228600" bIns="228600"/>
-          <a:lstStyle/>
-          <a:p>
-            <a:pPr algn="l"/>
-            <a:r>
-              <a:rPr sz="2200" b="1">
-                <a:solidFill>
-                  <a:srgbClr val="A8432F"/>
-                </a:solidFill>
-                <a:latin typeface="Calibri"/>
-              </a:rPr>
-              <a:t>А   </a:t>
-            </a:r>
-            <a:r>
-              <a:rPr sz="2200" b="0">
-                <a:solidFill>
-                  <a:srgbClr val="1B2A41"/>
-                </a:solidFill>
-                <a:latin typeface="Calibri"/>
-              </a:rPr>
-              <a:t>США → Англия → Европа</a:t>
-            </a:r>
-          </a:p>
-        </p:txBody>
-      </p:sp>
-      <p:sp>
-        <p:nvSpPr>
-          <p:cNvPr id="5" name="answer"/>
-          <p:cNvSpPr/>
-          <p:nvPr/>
-        </p:nvSpPr>
-        <p:spPr>
-          <a:xfrm>
-            <a:off x="731520" y="2250000"/>
-            <a:ext cx="10698480" cy="1050000"/>
-          </a:xfrm>
-          <a:prstGeom prst="roundRect">
-            <a:avLst>
-              <a:gd name="adj" fmla="val 12000"/>
-            </a:avLst>
-          </a:prstGeom>
-          <a:solidFill>
-            <a:srgbClr val="A8432F"/>
-          </a:solidFill>
-          <a:ln>
-            <a:solidFill>
-              <a:srgbClr val="A8432F"/>
-            </a:solidFill>
-          </a:ln>
-          <a:effectLst/>
-        </p:spPr>
-        <p:style>
-          <a:lnRef idx="1">
-            <a:schemeClr val="accent1"/>
-          </a:lnRef>
-          <a:fillRef idx="3">
-            <a:schemeClr val="accent1"/>
-          </a:fillRef>
-          <a:effectRef idx="2">
-            <a:schemeClr val="accent1"/>
-          </a:effectRef>
-          <a:fontRef idx="minor">
-            <a:schemeClr val="lt1"/>
-          </a:fontRef>
-        </p:style>
-        <p:txBody>
-          <a:bodyPr rtlCol="0" anchor="ctr" wrap="square" lIns="228600" rIns="228600" tIns="228600" bIns="228600"/>
-          <a:lstStyle/>
-          <a:p>
-            <a:pPr algn="l"/>
-            <a:r>
-              <a:rPr sz="2200" b="1">
-                <a:solidFill>
-                  <a:srgbClr val="D9A441"/>
-                </a:solidFill>
-                <a:latin typeface="Calibri"/>
-              </a:rPr>
-              <a:t>✓  А   </a:t>
-            </a:r>
-            <a:r>
-              <a:rPr sz="2200" b="1">
-                <a:solidFill>
-                  <a:srgbClr val="FFFFFF"/>
-                </a:solidFill>
-                <a:latin typeface="Calibri"/>
-              </a:rPr>
-              <a:t>США → Англия → Европа</a:t>
-            </a:r>
-          </a:p>
-        </p:txBody>
-      </p:sp>
-      <p:sp>
-        <p:nvSpPr>
-          <p:cNvPr id="6" name="Rounded Rectangle 5"/>
-          <p:cNvSpPr/>
-          <p:nvPr/>
-        </p:nvSpPr>
-        <p:spPr>
-          <a:xfrm>
-            <a:off x="731520" y="3470000"/>
-            <a:ext cx="10698480" cy="1050000"/>
-          </a:xfrm>
-          <a:prstGeom prst="roundRect">
-            <a:avLst>
-              <a:gd name="adj" fmla="val 12000"/>
-            </a:avLst>
-          </a:prstGeom>
-          <a:solidFill>
-            <a:srgbClr val="F4EFE7"/>
-          </a:solidFill>
-          <a:ln>
-            <a:solidFill>
-              <a:srgbClr val="F4EFE7"/>
-            </a:solidFill>
-          </a:ln>
-          <a:effectLst/>
-        </p:spPr>
-        <p:style>
-          <a:lnRef idx="1">
-            <a:schemeClr val="accent1"/>
-          </a:lnRef>
-          <a:fillRef idx="3">
-            <a:schemeClr val="accent1"/>
-          </a:fillRef>
-          <a:effectRef idx="2">
-            <a:schemeClr val="accent1"/>
-          </a:effectRef>
-          <a:fontRef idx="minor">
-            <a:schemeClr val="lt1"/>
-          </a:fontRef>
-        </p:style>
-        <p:txBody>
-          <a:bodyPr rtlCol="0" anchor="ctr" wrap="square" lIns="228600" rIns="228600" tIns="228600" bIns="228600"/>
-          <a:lstStyle/>
-          <a:p>
-            <a:pPr algn="l"/>
-            <a:r>
-              <a:rPr sz="2200" b="1">
-                <a:solidFill>
-                  <a:srgbClr val="A8432F"/>
-                </a:solidFill>
-                <a:latin typeface="Calibri"/>
-              </a:rPr>
-              <a:t>Б   </a:t>
-            </a:r>
-            <a:r>
-              <a:rPr sz="2200" b="0">
-                <a:solidFill>
-                  <a:srgbClr val="1B2A41"/>
-                </a:solidFill>
-                <a:latin typeface="Calibri"/>
-              </a:rPr>
-              <a:t>Англия → США → Россия</a:t>
-            </a:r>
-          </a:p>
-        </p:txBody>
-      </p:sp>
-      <p:sp>
-        <p:nvSpPr>
-          <p:cNvPr id="7" name="Rounded Rectangle 6"/>
-          <p:cNvSpPr/>
-          <p:nvPr/>
-        </p:nvSpPr>
-        <p:spPr>
-          <a:xfrm>
-            <a:off x="731520" y="4690000"/>
-            <a:ext cx="10698480" cy="1050000"/>
-          </a:xfrm>
-          <a:prstGeom prst="roundRect">
-            <a:avLst>
-              <a:gd name="adj" fmla="val 12000"/>
-            </a:avLst>
-          </a:prstGeom>
-          <a:solidFill>
-            <a:srgbClr val="F4EFE7"/>
-          </a:solidFill>
-          <a:ln>
-            <a:solidFill>
-              <a:srgbClr val="F4EFE7"/>
-            </a:solidFill>
-          </a:ln>
-          <a:effectLst/>
-        </p:spPr>
-        <p:style>
-          <a:lnRef idx="1">
-            <a:schemeClr val="accent1"/>
-          </a:lnRef>
-          <a:fillRef idx="3">
-            <a:schemeClr val="accent1"/>
-          </a:fillRef>
-          <a:effectRef idx="2">
-            <a:schemeClr val="accent1"/>
-          </a:effectRef>
-          <a:fontRef idx="minor">
-            <a:schemeClr val="lt1"/>
-          </a:fontRef>
-        </p:style>
-        <p:txBody>
-          <a:bodyPr rtlCol="0" anchor="ctr" wrap="square" lIns="228600" rIns="228600" tIns="228600" bIns="228600"/>
-          <a:lstStyle/>
-          <a:p>
-            <a:pPr algn="l"/>
-            <a:r>
-              <a:rPr sz="2200" b="1">
-                <a:solidFill>
-                  <a:srgbClr val="A8432F"/>
-                </a:solidFill>
-                <a:latin typeface="Calibri"/>
-              </a:rPr>
-              <a:t>В   </a:t>
-            </a:r>
-            <a:r>
-              <a:rPr sz="2200" b="0">
-                <a:solidFill>
-                  <a:srgbClr val="1B2A41"/>
-                </a:solidFill>
-                <a:latin typeface="Calibri"/>
-              </a:rPr>
-              <a:t>Европа → США → Англия</a:t>
-            </a:r>
-          </a:p>
-        </p:txBody>
-      </p:sp>
-      <p:sp>
-        <p:nvSpPr>
-          <p:cNvPr id="8" name="Rectangle 7"/>
-          <p:cNvSpPr/>
-          <p:nvPr/>
-        </p:nvSpPr>
-        <p:spPr>
-          <a:xfrm>
-            <a:off x="731520" y="6400000"/>
-            <a:ext cx="10698480" cy="274320"/>
-          </a:xfrm>
-          <a:prstGeom prst="rect">
-            <a:avLst/>
-          </a:prstGeom>
-          <a:noFill/>
-          <a:ln>
-            <a:noFill/>
-          </a:ln>
-          <a:effectLst/>
-        </p:spPr>
-        <p:style>
-          <a:lnRef idx="1">
-            <a:schemeClr val="accent1"/>
-          </a:lnRef>
-          <a:fillRef idx="3">
-            <a:schemeClr val="accent1"/>
-          </a:fillRef>
-          <a:effectRef idx="2">
-            <a:schemeClr val="accent1"/>
-          </a:effectRef>
-          <a:fontRef idx="minor">
-            <a:schemeClr val="lt1"/>
-          </a:fontRef>
-        </p:style>
-        <p:txBody>
-          <a:bodyPr rtlCol="0" anchor="ctr" wrap="square" lIns="0" rIns="0" tIns="0" bIns="0"/>
-          <a:lstStyle/>
-          <a:p>
-            <a:pPr algn="l"/>
-            <a:r>
-              <a:rPr sz="1100" b="0">
-                <a:solidFill>
-                  <a:srgbClr val="6B7686"/>
-                </a:solidFill>
-                <a:latin typeface="Calibri"/>
-              </a:rPr>
-              <a:t>Нажмите — правильный ответ подсветится</a:t>
-            </a:r>
-          </a:p>
-        </p:txBody>
-      </p:sp>
-    </p:spTree>
-  </p:cSld>
-  <p:clrMapOvr>
-    <a:masterClrMapping/>
-  </p:clrMapOvr>
-  <p:timing>
-    <p:tnLst>
-      <p:par>
-        <p:cTn id="1" dur="indefinite" restart="never" nodeType="tmRoot">
-          <p:childTnLst>
-            <p:seq concurrent="1" nextAc="seek">
-              <p:cTn id="2" dur="indefinite" nodeType="mainSeq">
-                <p:childTnLst>
-                  <p:par>
-                    <p:cTn id="3" fill="hold">
-                      <p:stCondLst>
-                        <p:cond delay="indefinite"/>
-                      </p:stCondLst>
-                      <p:childTnLst>
-                        <p:par>
-                          <p:cTn id="4" fill="hold">
-                            <p:stCondLst>
-                              <p:cond delay="0"/>
-                            </p:stCondLst>
-                            <p:childTnLst>
-                              <p:par>
-                                <p:cTn id="5" presetID="10" presetClass="entr" presetSubtype="0" fill="hold" grpId="0" nodeType="clickEffect">
-                                  <p:stCondLst>
-                                    <p:cond delay="0"/>
-                                  </p:stCondLst>
-                                  <p:childTnLst>
-                                    <p:set>
-                                      <p:cBhvr>
-                                        <p:cTn id="6" dur="1" fill="hold">
-                                          <p:stCondLst>
-                                            <p:cond delay="0"/>
-                                          </p:stCondLst>
-                                        </p:cTn>
-                                        <p:tgtEl>
-                                          <p:spTgt spid="5"/>
-                                        </p:tgtEl>
-                                        <p:attrNameLst>
-                                          <p:attrName>style.visibility</p:attrName>
-                                        </p:attrNameLst>
-                                      </p:cBhvr>
-                                      <p:to>
-                                        <p:strVal val="visible"/>
-                                      </p:to>
-                                    </p:set>
-                                    <p:animEffect transition="in" filter="fade">
-                                      <p:cBhvr>
-                                        <p:cTn id="7" dur="500"/>
-                                        <p:tgtEl>
-                                          <p:spTgt spid="5"/>
-                                        </p:tgtEl>
-                                      </p:cBhvr>
-                                    </p:animEffect>
-                                  </p:childTnLst>
-                                </p:cTn>
-                              </p:par>
-                            </p:childTnLst>
-                          </p:cTn>
-                        </p:par>
-                      </p:childTnLst>
-                    </p:cTn>
-                  </p:par>
-                </p:childTnLst>
-              </p:cTn>
-              <p:prevCondLst>
-                <p:cond evt="onPrev" delay="0">
-                  <p:tgtEl>
-                    <p:sldTgt/>
-                  </p:tgtEl>
-                </p:cond>
-              </p:prevCondLst>
-              <p:nextCondLst>
-                <p:cond evt="onNext" delay="0">
-                  <p:tgtEl>
-                    <p:sldTgt/>
-                  </p:tgtEl>
-                </p:cond>
-              </p:nextCondLst>
-            </p:seq>
-          </p:childTnLst>
-        </p:cTn>
-      </p:par>
-    </p:tnLst>
-    <p:bldLst>
-      <p:bldP spid="5" grpId="0" animBg="1"/>
-    </p:bldLst>
-  </p:timing>
-</p:sld>
-</file>
-
-<file path=ppt/slides/slide11.xml><?xml version="1.0" encoding="utf-8"?>
-<p:sld xmlns:a="http://schemas.openxmlformats.org/drawingml/2006/main" xmlns:p="http://schemas.openxmlformats.org/presentationml/2006/main" xmlns:r="http://schemas.openxmlformats.org/officeDocument/2006/relationships">
-  <p:cSld>
-    <p:bg>
-      <p:bgPr>
-        <a:solidFill>
-          <a:srgbClr val="FFFFFF"/>
-        </a:solidFill>
-        <a:effectLst/>
-      </p:bgPr>
-    </p:bg>
-    <p:spTree>
-      <p:nvGrpSpPr>
-        <p:cNvPr id="1" name=""/>
-        <p:cNvGrpSpPr/>
-        <p:nvPr/>
-      </p:nvGrpSpPr>
-      <p:grpSpPr/>
-      <p:sp>
-        <p:nvSpPr>
-          <p:cNvPr id="2" name="Rectangle 1"/>
-          <p:cNvSpPr/>
-          <p:nvPr/>
-        </p:nvSpPr>
-        <p:spPr>
-          <a:xfrm>
-            <a:off x="731520" y="502920"/>
-            <a:ext cx="10698480" cy="274320"/>
-          </a:xfrm>
-          <a:prstGeom prst="rect">
-            <a:avLst/>
-          </a:prstGeom>
-          <a:noFill/>
-          <a:ln>
-            <a:noFill/>
-          </a:ln>
-          <a:effectLst/>
-        </p:spPr>
-        <p:style>
-          <a:lnRef idx="1">
-            <a:schemeClr val="accent1"/>
-          </a:lnRef>
-          <a:fillRef idx="3">
-            <a:schemeClr val="accent1"/>
-          </a:fillRef>
-          <a:effectRef idx="2">
-            <a:schemeClr val="accent1"/>
-          </a:effectRef>
-          <a:fontRef idx="minor">
-            <a:schemeClr val="lt1"/>
-          </a:fontRef>
-        </p:style>
-        <p:txBody>
-          <a:bodyPr rtlCol="0" anchor="ctr" wrap="square" lIns="0" rIns="0" tIns="0" bIns="0"/>
-          <a:lstStyle/>
-          <a:p>
-            <a:pPr algn="l"/>
-            <a:r>
-              <a:rPr sz="1200" b="1" spc="300">
-                <a:solidFill>
-                  <a:srgbClr val="A8432F"/>
-                </a:solidFill>
-                <a:latin typeface="Calibri"/>
-              </a:rPr>
-              <a:t>ВИКТОРИНА · 6 / 6</a:t>
-            </a:r>
-          </a:p>
-        </p:txBody>
-      </p:sp>
-      <p:sp>
-        <p:nvSpPr>
-          <p:cNvPr id="3" name="Rectangle 2"/>
-          <p:cNvSpPr/>
-          <p:nvPr/>
-        </p:nvSpPr>
-        <p:spPr>
-          <a:xfrm>
-            <a:off x="731520" y="850000"/>
-            <a:ext cx="10698480" cy="1200000"/>
-          </a:xfrm>
-          <a:prstGeom prst="rect">
-            <a:avLst/>
-          </a:prstGeom>
-          <a:noFill/>
-          <a:ln>
-            <a:noFill/>
-          </a:ln>
-          <a:effectLst/>
-        </p:spPr>
-        <p:style>
-          <a:lnRef idx="1">
-            <a:schemeClr val="accent1"/>
-          </a:lnRef>
-          <a:fillRef idx="3">
-            <a:schemeClr val="accent1"/>
-          </a:fillRef>
-          <a:effectRef idx="2">
-            <a:schemeClr val="accent1"/>
-          </a:effectRef>
-          <a:fontRef idx="minor">
-            <a:schemeClr val="lt1"/>
-          </a:fontRef>
-        </p:style>
-        <p:txBody>
-          <a:bodyPr rtlCol="0" anchor="t" wrap="square" lIns="0" rIns="0" tIns="0" bIns="0"/>
-          <a:lstStyle/>
-          <a:p>
-            <a:pPr algn="l"/>
-            <a:r>
-              <a:rPr sz="2800" b="1">
-                <a:solidFill>
-                  <a:srgbClr val="1B2A41"/>
-                </a:solidFill>
-                <a:latin typeface="Cambria"/>
-              </a:rPr>
-              <a:t>Как менялись цены, когда кризис углублялся?</a:t>
-            </a:r>
-          </a:p>
-        </p:txBody>
-      </p:sp>
-      <p:sp>
-        <p:nvSpPr>
-          <p:cNvPr id="4" name="Rounded Rectangle 3"/>
-          <p:cNvSpPr/>
-          <p:nvPr/>
-        </p:nvSpPr>
-        <p:spPr>
-          <a:xfrm>
-            <a:off x="731520" y="2250000"/>
-            <a:ext cx="10698480" cy="1050000"/>
-          </a:xfrm>
-          <a:prstGeom prst="roundRect">
-            <a:avLst>
-              <a:gd name="adj" fmla="val 12000"/>
-            </a:avLst>
-          </a:prstGeom>
-          <a:solidFill>
-            <a:srgbClr val="F4EFE7"/>
-          </a:solidFill>
-          <a:ln>
-            <a:solidFill>
-              <a:srgbClr val="F4EFE7"/>
-            </a:solidFill>
-          </a:ln>
-          <a:effectLst/>
-        </p:spPr>
-        <p:style>
-          <a:lnRef idx="1">
-            <a:schemeClr val="accent1"/>
-          </a:lnRef>
-          <a:fillRef idx="3">
-            <a:schemeClr val="accent1"/>
-          </a:fillRef>
-          <a:effectRef idx="2">
-            <a:schemeClr val="accent1"/>
-          </a:effectRef>
-          <a:fontRef idx="minor">
-            <a:schemeClr val="lt1"/>
-          </a:fontRef>
-        </p:style>
-        <p:txBody>
-          <a:bodyPr rtlCol="0" anchor="ctr" wrap="square" lIns="228600" rIns="228600" tIns="228600" bIns="228600"/>
-          <a:lstStyle/>
-          <a:p>
-            <a:pPr algn="l"/>
-            <a:r>
-              <a:rPr sz="2200" b="1">
-                <a:solidFill>
-                  <a:srgbClr val="A8432F"/>
-                </a:solidFill>
-                <a:latin typeface="Calibri"/>
-              </a:rPr>
-              <a:t>А   </a:t>
-            </a:r>
-            <a:r>
-              <a:rPr sz="2200" b="0">
-                <a:solidFill>
-                  <a:srgbClr val="1B2A41"/>
-                </a:solidFill>
-                <a:latin typeface="Calibri"/>
-              </a:rPr>
-              <a:t>Резко росли</a:t>
-            </a:r>
-          </a:p>
-        </p:txBody>
-      </p:sp>
-      <p:sp>
-        <p:nvSpPr>
-          <p:cNvPr id="5" name="Rounded Rectangle 4"/>
-          <p:cNvSpPr/>
-          <p:nvPr/>
-        </p:nvSpPr>
-        <p:spPr>
-          <a:xfrm>
-            <a:off x="731520" y="3470000"/>
-            <a:ext cx="10698480" cy="1050000"/>
-          </a:xfrm>
-          <a:prstGeom prst="roundRect">
-            <a:avLst>
-              <a:gd name="adj" fmla="val 12000"/>
-            </a:avLst>
-          </a:prstGeom>
-          <a:solidFill>
-            <a:srgbClr val="F4EFE7"/>
-          </a:solidFill>
-          <a:ln>
-            <a:solidFill>
-              <a:srgbClr val="F4EFE7"/>
-            </a:solidFill>
-          </a:ln>
-          <a:effectLst/>
-        </p:spPr>
-        <p:style>
-          <a:lnRef idx="1">
-            <a:schemeClr val="accent1"/>
-          </a:lnRef>
-          <a:fillRef idx="3">
-            <a:schemeClr val="accent1"/>
-          </a:fillRef>
-          <a:effectRef idx="2">
-            <a:schemeClr val="accent1"/>
-          </a:effectRef>
-          <a:fontRef idx="minor">
-            <a:schemeClr val="lt1"/>
-          </a:fontRef>
-        </p:style>
-        <p:txBody>
-          <a:bodyPr rtlCol="0" anchor="ctr" wrap="square" lIns="228600" rIns="228600" tIns="228600" bIns="228600"/>
-          <a:lstStyle/>
-          <a:p>
-            <a:pPr algn="l"/>
-            <a:r>
-              <a:rPr sz="2200" b="1">
-                <a:solidFill>
-                  <a:srgbClr val="A8432F"/>
-                </a:solidFill>
-                <a:latin typeface="Calibri"/>
-              </a:rPr>
-              <a:t>Б   </a:t>
-            </a:r>
-            <a:r>
-              <a:rPr sz="2200" b="0">
-                <a:solidFill>
-                  <a:srgbClr val="1B2A41"/>
-                </a:solidFill>
-                <a:latin typeface="Calibri"/>
-              </a:rPr>
-              <a:t>Оставались прежними</a:t>
-            </a:r>
-          </a:p>
-        </p:txBody>
-      </p:sp>
-      <p:sp>
-        <p:nvSpPr>
-          <p:cNvPr id="6" name="Rounded Rectangle 5"/>
-          <p:cNvSpPr/>
-          <p:nvPr/>
-        </p:nvSpPr>
-        <p:spPr>
-          <a:xfrm>
-            <a:off x="731520" y="4690000"/>
-            <a:ext cx="10698480" cy="1050000"/>
-          </a:xfrm>
-          <a:prstGeom prst="roundRect">
-            <a:avLst>
-              <a:gd name="adj" fmla="val 12000"/>
-            </a:avLst>
-          </a:prstGeom>
-          <a:solidFill>
-            <a:srgbClr val="F4EFE7"/>
-          </a:solidFill>
-          <a:ln>
-            <a:solidFill>
-              <a:srgbClr val="F4EFE7"/>
-            </a:solidFill>
-          </a:ln>
-          <a:effectLst/>
-        </p:spPr>
-        <p:style>
-          <a:lnRef idx="1">
-            <a:schemeClr val="accent1"/>
-          </a:lnRef>
-          <a:fillRef idx="3">
-            <a:schemeClr val="accent1"/>
-          </a:fillRef>
-          <a:effectRef idx="2">
-            <a:schemeClr val="accent1"/>
-          </a:effectRef>
-          <a:fontRef idx="minor">
-            <a:schemeClr val="lt1"/>
-          </a:fontRef>
-        </p:style>
-        <p:txBody>
-          <a:bodyPr rtlCol="0" anchor="ctr" wrap="square" lIns="228600" rIns="228600" tIns="228600" bIns="228600"/>
-          <a:lstStyle/>
-          <a:p>
-            <a:pPr algn="l"/>
-            <a:r>
-              <a:rPr sz="2200" b="1">
-                <a:solidFill>
-                  <a:srgbClr val="A8432F"/>
-                </a:solidFill>
-                <a:latin typeface="Calibri"/>
-              </a:rPr>
-              <a:t>В   </a:t>
-            </a:r>
-            <a:r>
-              <a:rPr sz="2200" b="0">
-                <a:solidFill>
-                  <a:srgbClr val="1B2A41"/>
-                </a:solidFill>
-                <a:latin typeface="Calibri"/>
-              </a:rPr>
-              <a:t>Постепенно падали</a:t>
-            </a:r>
-          </a:p>
-        </p:txBody>
-      </p:sp>
-      <p:sp>
-        <p:nvSpPr>
-          <p:cNvPr id="7" name="answer"/>
-          <p:cNvSpPr/>
-          <p:nvPr/>
-        </p:nvSpPr>
-        <p:spPr>
-          <a:xfrm>
-            <a:off x="731520" y="4690000"/>
-            <a:ext cx="10698480" cy="1050000"/>
-          </a:xfrm>
-          <a:prstGeom prst="roundRect">
-            <a:avLst>
-              <a:gd name="adj" fmla="val 12000"/>
-            </a:avLst>
-          </a:prstGeom>
-          <a:solidFill>
-            <a:srgbClr val="A8432F"/>
-          </a:solidFill>
-          <a:ln>
-            <a:solidFill>
-              <a:srgbClr val="A8432F"/>
-            </a:solidFill>
-          </a:ln>
-          <a:effectLst/>
-        </p:spPr>
-        <p:style>
-          <a:lnRef idx="1">
-            <a:schemeClr val="accent1"/>
-          </a:lnRef>
-          <a:fillRef idx="3">
-            <a:schemeClr val="accent1"/>
-          </a:fillRef>
-          <a:effectRef idx="2">
-            <a:schemeClr val="accent1"/>
-          </a:effectRef>
-          <a:fontRef idx="minor">
-            <a:schemeClr val="lt1"/>
-          </a:fontRef>
-        </p:style>
-        <p:txBody>
-          <a:bodyPr rtlCol="0" anchor="ctr" wrap="square" lIns="228600" rIns="228600" tIns="228600" bIns="228600"/>
-          <a:lstStyle/>
-          <a:p>
-            <a:pPr algn="l"/>
-            <a:r>
-              <a:rPr sz="2200" b="1">
-                <a:solidFill>
-                  <a:srgbClr val="D9A441"/>
-                </a:solidFill>
-                <a:latin typeface="Calibri"/>
-              </a:rPr>
-              <a:t>✓  В   </a:t>
-            </a:r>
-            <a:r>
-              <a:rPr sz="2200" b="1">
-                <a:solidFill>
-                  <a:srgbClr val="FFFFFF"/>
-                </a:solidFill>
-                <a:latin typeface="Calibri"/>
-              </a:rPr>
-              <a:t>Постепенно падали</a:t>
-            </a:r>
-          </a:p>
-        </p:txBody>
-      </p:sp>
-      <p:sp>
-        <p:nvSpPr>
-          <p:cNvPr id="8" name="Rectangle 7"/>
-          <p:cNvSpPr/>
-          <p:nvPr/>
-        </p:nvSpPr>
-        <p:spPr>
-          <a:xfrm>
-            <a:off x="731520" y="6400000"/>
-            <a:ext cx="10698480" cy="274320"/>
-          </a:xfrm>
-          <a:prstGeom prst="rect">
-            <a:avLst/>
-          </a:prstGeom>
-          <a:noFill/>
-          <a:ln>
-            <a:noFill/>
-          </a:ln>
-          <a:effectLst/>
-        </p:spPr>
-        <p:style>
-          <a:lnRef idx="1">
-            <a:schemeClr val="accent1"/>
-          </a:lnRef>
-          <a:fillRef idx="3">
-            <a:schemeClr val="accent1"/>
-          </a:fillRef>
-          <a:effectRef idx="2">
-            <a:schemeClr val="accent1"/>
-          </a:effectRef>
-          <a:fontRef idx="minor">
-            <a:schemeClr val="lt1"/>
-          </a:fontRef>
-        </p:style>
-        <p:txBody>
-          <a:bodyPr rtlCol="0" anchor="ctr" wrap="square" lIns="0" rIns="0" tIns="0" bIns="0"/>
-          <a:lstStyle/>
-          <a:p>
-            <a:pPr algn="l"/>
-            <a:r>
-              <a:rPr sz="1100" b="0">
-                <a:solidFill>
-                  <a:srgbClr val="6B7686"/>
-                </a:solidFill>
-                <a:latin typeface="Calibri"/>
-              </a:rPr>
-              <a:t>Нажмите — правильный ответ подсветится</a:t>
-            </a:r>
-          </a:p>
-        </p:txBody>
-      </p:sp>
-    </p:spTree>
-  </p:cSld>
-  <p:clrMapOvr>
-    <a:masterClrMapping/>
-  </p:clrMapOvr>
-  <p:timing>
-    <p:tnLst>
-      <p:par>
-        <p:cTn id="1" dur="indefinite" restart="never" nodeType="tmRoot">
-          <p:childTnLst>
-            <p:seq concurrent="1" nextAc="seek">
-              <p:cTn id="2" dur="indefinite" nodeType="mainSeq">
-                <p:childTnLst>
-                  <p:par>
-                    <p:cTn id="3" fill="hold">
-                      <p:stCondLst>
-                        <p:cond delay="indefinite"/>
-                      </p:stCondLst>
-                      <p:childTnLst>
-                        <p:par>
-                          <p:cTn id="4" fill="hold">
-                            <p:stCondLst>
-                              <p:cond delay="0"/>
-                            </p:stCondLst>
-                            <p:childTnLst>
-                              <p:par>
-                                <p:cTn id="5" presetID="10" presetClass="entr" presetSubtype="0" fill="hold" grpId="0" nodeType="clickEffect">
-                                  <p:stCondLst>
-                                    <p:cond delay="0"/>
-                                  </p:stCondLst>
-                                  <p:childTnLst>
-                                    <p:set>
-                                      <p:cBhvr>
-                                        <p:cTn id="6" dur="1" fill="hold">
-                                          <p:stCondLst>
-                                            <p:cond delay="0"/>
-                                          </p:stCondLst>
-                                        </p:cTn>
-                                        <p:tgtEl>
-                                          <p:spTgt spid="7"/>
-                                        </p:tgtEl>
-                                        <p:attrNameLst>
-                                          <p:attrName>style.visibility</p:attrName>
-                                        </p:attrNameLst>
-                                      </p:cBhvr>
-                                      <p:to>
-                                        <p:strVal val="visible"/>
-                                      </p:to>
-                                    </p:set>
-                                    <p:animEffect transition="in" filter="fade">
-                                      <p:cBhvr>
-                                        <p:cTn id="7" dur="500"/>
-                                        <p:tgtEl>
-                                          <p:spTgt spid="7"/>
-                                        </p:tgtEl>
-                                      </p:cBhvr>
-                                    </p:animEffect>
-                                  </p:childTnLst>
-                                </p:cTn>
-                              </p:par>
-                            </p:childTnLst>
-                          </p:cTn>
-                        </p:par>
-                      </p:childTnLst>
-                    </p:cTn>
-                  </p:par>
-                </p:childTnLst>
-              </p:cTn>
-              <p:prevCondLst>
-                <p:cond evt="onPrev" delay="0">
-                  <p:tgtEl>
-                    <p:sldTgt/>
-                  </p:tgtEl>
-                </p:cond>
-              </p:prevCondLst>
-              <p:nextCondLst>
-                <p:cond evt="onNext" delay="0">
-                  <p:tgtEl>
-                    <p:sldTgt/>
-                  </p:tgtEl>
-                </p:cond>
-              </p:nextCondLst>
-            </p:seq>
-          </p:childTnLst>
-        </p:cTn>
-      </p:par>
-    </p:tnLst>
-    <p:bldLst>
-      <p:bldP spid="7" grpId="0" animBg="1"/>
-    </p:bldLst>
-  </p:timing>
-</p:sld>
-</file>
-
-<file path=ppt/slides/slide12.xml><?xml version="1.0" encoding="utf-8"?>
-<p:sld xmlns:a="http://schemas.openxmlformats.org/drawingml/2006/main" xmlns:p="http://schemas.openxmlformats.org/presentationml/2006/main" xmlns:r="http://schemas.openxmlformats.org/officeDocument/2006/relationships">
-  <p:cSld>
-    <p:bg>
-      <p:bgPr>
-        <a:solidFill>
-          <a:srgbClr val="1B2A41"/>
-        </a:solidFill>
-        <a:effectLst/>
-      </p:bgPr>
-    </p:bg>
-    <p:spTree>
-      <p:nvGrpSpPr>
-        <p:cNvPr id="1" name=""/>
-        <p:cNvGrpSpPr/>
-        <p:nvPr/>
-      </p:nvGrpSpPr>
-      <p:grpSpPr/>
-      <p:sp>
-        <p:nvSpPr>
-          <p:cNvPr id="2" name="Rectangle 1"/>
-          <p:cNvSpPr/>
-          <p:nvPr/>
-        </p:nvSpPr>
-        <p:spPr>
-          <a:xfrm>
-            <a:off x="731520" y="2500000"/>
-            <a:ext cx="10698480" cy="1100000"/>
-          </a:xfrm>
-          <a:prstGeom prst="rect">
-            <a:avLst/>
-          </a:prstGeom>
-          <a:noFill/>
-          <a:ln>
-            <a:noFill/>
-          </a:ln>
-          <a:effectLst/>
-        </p:spPr>
-        <p:style>
-          <a:lnRef idx="1">
-            <a:schemeClr val="accent1"/>
-          </a:lnRef>
-          <a:fillRef idx="3">
-            <a:schemeClr val="accent1"/>
-          </a:fillRef>
-          <a:effectRef idx="2">
-            <a:schemeClr val="accent1"/>
-          </a:effectRef>
-          <a:fontRef idx="minor">
-            <a:schemeClr val="lt1"/>
-          </a:fontRef>
-        </p:style>
-        <p:txBody>
-          <a:bodyPr rtlCol="0" anchor="ctr" wrap="square" lIns="0" rIns="0" tIns="0" bIns="0"/>
-          <a:lstStyle/>
-          <a:p>
-            <a:pPr algn="l"/>
-            <a:r>
-              <a:rPr sz="5400" b="1">
-                <a:solidFill>
-                  <a:srgbClr val="FFFFFF"/>
-                </a:solidFill>
-                <a:latin typeface="Cambria"/>
-              </a:rPr>
-              <a:t>Молодец!</a:t>
-            </a:r>
-          </a:p>
-        </p:txBody>
-      </p:sp>
-      <p:sp>
-        <p:nvSpPr>
-          <p:cNvPr id="3" name="Rectangle 2"/>
-          <p:cNvSpPr/>
-          <p:nvPr/>
-        </p:nvSpPr>
-        <p:spPr>
-          <a:xfrm>
-            <a:off x="731520" y="3700000"/>
-            <a:ext cx="914400" cy="45720"/>
-          </a:xfrm>
-          <a:prstGeom prst="rect">
-            <a:avLst/>
-          </a:prstGeom>
-          <a:solidFill>
-            <a:srgbClr val="D9A441"/>
-          </a:solidFill>
-          <a:ln>
-            <a:solidFill>
-              <a:srgbClr val="D9A441"/>
-            </a:solidFill>
-          </a:ln>
-          <a:effectLst/>
-        </p:spPr>
-        <p:style>
-          <a:lnRef idx="1">
-            <a:schemeClr val="accent1"/>
-          </a:lnRef>
-          <a:fillRef idx="3">
-            <a:schemeClr val="accent1"/>
-          </a:fillRef>
-          <a:effectRef idx="2">
-            <a:schemeClr val="accent1"/>
-          </a:effectRef>
-          <a:fontRef idx="minor">
-            <a:schemeClr val="lt1"/>
-          </a:fontRef>
-        </p:style>
-        <p:txBody>
-          <a:bodyPr rtlCol="0" anchor="ctr" wrap="square" lIns="0" rIns="0" tIns="0" bIns="0"/>
-          <a:lstStyle/>
-          <a:p>
-            <a:pPr algn="l"/>
-            <a:r>
-              <a:rPr sz="100" b="0">
-                <a:solidFill>
-                  <a:srgbClr val="D9A441"/>
-                </a:solidFill>
-                <a:latin typeface="Calibri"/>
-              </a:rPr>
-              <a:t/>
-            </a:r>
-          </a:p>
-        </p:txBody>
-      </p:sp>
-      <p:sp>
-        <p:nvSpPr>
-          <p:cNvPr id="4" name="Rectangle 3"/>
-          <p:cNvSpPr/>
-          <p:nvPr/>
-        </p:nvSpPr>
-        <p:spPr>
-          <a:xfrm>
-            <a:off x="731520" y="3950000"/>
-            <a:ext cx="10698480" cy="600000"/>
-          </a:xfrm>
-          <a:prstGeom prst="rect">
-            <a:avLst/>
-          </a:prstGeom>
-          <a:noFill/>
-          <a:ln>
-            <a:noFill/>
-          </a:ln>
-          <a:effectLst/>
-        </p:spPr>
-        <p:style>
-          <a:lnRef idx="1">
-            <a:schemeClr val="accent1"/>
-          </a:lnRef>
-          <a:fillRef idx="3">
-            <a:schemeClr val="accent1"/>
-          </a:fillRef>
-          <a:effectRef idx="2">
-            <a:schemeClr val="accent1"/>
-          </a:effectRef>
-          <a:fontRef idx="minor">
-            <a:schemeClr val="lt1"/>
-          </a:fontRef>
-        </p:style>
-        <p:txBody>
-          <a:bodyPr rtlCol="0" anchor="ctr" wrap="square" lIns="0" rIns="0" tIns="0" bIns="0"/>
-          <a:lstStyle/>
-          <a:p>
-            <a:pPr algn="l"/>
-            <a:r>
-              <a:rPr sz="2000" b="0">
-                <a:solidFill>
-                  <a:srgbClr val="C9D1DC"/>
-                </a:solidFill>
-                <a:latin typeface="Calibri"/>
-              </a:rPr>
-              <a:t>Тема пройдена: экономические кризисы XIX–XX веков</a:t>
-            </a:r>
-          </a:p>
-        </p:txBody>
-      </p:sp>
-    </p:spTree>
-  </p:cSld>
-  <p:clrMapOvr>
-    <a:masterClrMapping/>
-  </p:clrMapOvr>
-</p:sld>
-</file>
-
 <file path=ppt/slides/slide2.xml><?xml version="1.0" encoding="utf-8"?>
 <p:sld xmlns:a="http://schemas.openxmlformats.org/drawingml/2006/main" xmlns:r="http://schemas.openxmlformats.org/officeDocument/2006/relationships" xmlns:p="http://schemas.openxmlformats.org/presentationml/2006/main">
   <p:cSld name="Slide 2">
@@ -6164,7 +4710,7 @@
                 </a:solidFill>
                 <a:latin typeface="Calibri"/>
               </a:rPr>
-              <a:t>6 вопросов · выбери правильный ответ</a:t>
+              <a:t>3 вопроса · выбери правильный ответ</a:t>
             </a:r>
           </a:p>
         </p:txBody>
@@ -6241,7 +4787,7 @@
                 </a:solidFill>
                 <a:latin typeface="Calibri"/>
               </a:rPr>
-              <a:t>ВИКТОРИНА · 1 / 6</a:t>
+              <a:t>ВИКТОРИНА · 1 / 3</a:t>
             </a:r>
           </a:p>
         </p:txBody>
@@ -6770,7 +5316,7 @@
                 </a:solidFill>
                 <a:latin typeface="Calibri"/>
               </a:rPr>
-              <a:t>ВИКТОРИНА · 2 / 6</a:t>
+              <a:t>ВИКТОРИНА · 2 / 3</a:t>
             </a:r>
           </a:p>
         </p:txBody>
@@ -6821,7 +5367,7 @@
                 </a:solidFill>
                 <a:latin typeface="Cambria"/>
               </a:rPr>
-              <a:t>Какие страны охватил кризис 1847 года?</a:t>
+              <a:t>Какую отрасль кризис 1900–1902 годов поразил первой?</a:t>
             </a:r>
           </a:p>
         </p:txBody>
@@ -6887,7 +5433,7 @@
                 </a:solidFill>
                 <a:latin typeface="Calibri"/>
               </a:rPr>
-              <a:t>Только Англию</a:t>
+              <a:t>Швейную промышленность</a:t>
             </a:r>
           </a:p>
         </p:txBody>
@@ -6953,7 +5499,7 @@
                 </a:solidFill>
                 <a:latin typeface="Calibri"/>
               </a:rPr>
-              <a:t>США, Англию, Францию и Германию</a:t>
+              <a:t>Металлургическую промышленность</a:t>
             </a:r>
           </a:p>
         </p:txBody>
@@ -7019,7 +5565,7 @@
                 </a:solidFill>
                 <a:latin typeface="Calibri"/>
               </a:rPr>
-              <a:t>США, Англию, Францию и Германию</a:t>
+              <a:t>Металлургическую промышленность</a:t>
             </a:r>
           </a:p>
         </p:txBody>
@@ -7085,7 +5631,7 @@
                 </a:solidFill>
                 <a:latin typeface="Calibri"/>
               </a:rPr>
-              <a:t>Россию и США</a:t>
+              <a:t>Химическую промышленность</a:t>
             </a:r>
           </a:p>
         </p:txBody>
@@ -7299,7 +5845,7 @@
                 </a:solidFill>
                 <a:latin typeface="Calibri"/>
               </a:rPr>
-              <a:t>ВИКТОРИНА · 3 / 6</a:t>
+              <a:t>ВИКТОРИНА · 3 / 3</a:t>
             </a:r>
           </a:p>
         </p:txBody>
@@ -7350,7 +5896,7 @@
                 </a:solidFill>
                 <a:latin typeface="Cambria"/>
               </a:rPr>
-              <a:t>Где одновременно начался самый тяжёлый кризис 1900–1902 годов?</a:t>
+              <a:t>Как менялись цены, когда кризис углублялся?</a:t>
             </a:r>
           </a:p>
         </p:txBody>
@@ -7416,7 +5962,7 @@
                 </a:solidFill>
                 <a:latin typeface="Calibri"/>
               </a:rPr>
-              <a:t>В Англии и Франции</a:t>
+              <a:t>Резко росли</a:t>
             </a:r>
           </a:p>
         </p:txBody>
@@ -7482,7 +6028,7 @@
                 </a:solidFill>
                 <a:latin typeface="Calibri"/>
               </a:rPr>
-              <a:t>В Германии и Англии</a:t>
+              <a:t>Оставались прежними</a:t>
             </a:r>
           </a:p>
         </p:txBody>
@@ -7548,7 +6094,7 @@
                 </a:solidFill>
                 <a:latin typeface="Calibri"/>
               </a:rPr>
-              <a:t>В России и США</a:t>
+              <a:t>Постепенно падали</a:t>
             </a:r>
           </a:p>
         </p:txBody>
@@ -7614,7 +6160,7 @@
                 </a:solidFill>
                 <a:latin typeface="Calibri"/>
               </a:rPr>
-              <a:t>В России и США</a:t>
+              <a:t>Постепенно падали</a:t>
             </a:r>
           </a:p>
         </p:txBody>
@@ -7770,7 +6316,7 @@
     <p:bg>
       <p:bgPr>
         <a:solidFill>
-          <a:srgbClr val="FFFFFF"/>
+          <a:srgbClr val="1B2A41"/>
         </a:solidFill>
         <a:effectLst/>
       </p:bgPr>
@@ -7790,8 +6336,8 @@
         </p:nvSpPr>
         <p:spPr>
           <a:xfrm>
-            <a:off x="731520" y="502920"/>
-            <a:ext cx="10698480" cy="274320"/>
+            <a:off x="731520" y="2500000"/>
+            <a:ext cx="10698480" cy="1100000"/>
           </a:xfrm>
           <a:prstGeom prst="rect">
             <a:avLst/>
@@ -7822,13 +6368,13 @@
           <a:p>
             <a:pPr algn="l"/>
             <a:r>
-              <a:rPr sz="1200" b="1" spc="300">
-                <a:solidFill>
-                  <a:srgbClr val="A8432F"/>
-                </a:solidFill>
-                <a:latin typeface="Calibri"/>
-              </a:rPr>
-              <a:t>ВИКТОРИНА · 4 / 6</a:t>
+              <a:rPr sz="5400" b="1">
+                <a:solidFill>
+                  <a:srgbClr val="FFFFFF"/>
+                </a:solidFill>
+                <a:latin typeface="Cambria"/>
+              </a:rPr>
+              <a:t>Молодец!</a:t>
             </a:r>
           </a:p>
         </p:txBody>
@@ -7841,8 +6387,63 @@
         </p:nvSpPr>
         <p:spPr>
           <a:xfrm>
-            <a:off x="731520" y="850000"/>
-            <a:ext cx="10698480" cy="1200000"/>
+            <a:off x="731520" y="3700000"/>
+            <a:ext cx="914400" cy="45720"/>
+          </a:xfrm>
+          <a:prstGeom prst="rect">
+            <a:avLst/>
+          </a:prstGeom>
+          <a:solidFill>
+            <a:srgbClr val="D9A441"/>
+          </a:solidFill>
+          <a:ln>
+            <a:solidFill>
+              <a:srgbClr val="D9A441"/>
+            </a:solidFill>
+          </a:ln>
+          <a:effectLst/>
+        </p:spPr>
+        <p:style>
+          <a:lnRef idx="1">
+            <a:schemeClr val="accent1"/>
+          </a:lnRef>
+          <a:fillRef idx="3">
+            <a:schemeClr val="accent1"/>
+          </a:fillRef>
+          <a:effectRef idx="2">
+            <a:schemeClr val="accent1"/>
+          </a:effectRef>
+          <a:fontRef idx="minor">
+            <a:schemeClr val="lt1"/>
+          </a:fontRef>
+        </p:style>
+        <p:txBody>
+          <a:bodyPr rtlCol="0" anchor="ctr" wrap="square" lIns="0" rIns="0" tIns="0" bIns="0"/>
+          <a:lstStyle/>
+          <a:p>
+            <a:pPr algn="l"/>
+            <a:r>
+              <a:rPr sz="100" b="0">
+                <a:solidFill>
+                  <a:srgbClr val="D9A441"/>
+                </a:solidFill>
+                <a:latin typeface="Calibri"/>
+              </a:rPr>
+              <a:t/>
+            </a:r>
+          </a:p>
+        </p:txBody>
+      </p:sp>
+      <p:sp>
+        <p:nvSpPr>
+          <p:cNvPr id="4" name="Rectangle 3"/>
+          <p:cNvSpPr/>
+          <p:nvPr/>
+        </p:nvSpPr>
+        <p:spPr>
+          <a:xfrm>
+            <a:off x="731520" y="3950000"/>
+            <a:ext cx="10698480" cy="600000"/>
           </a:xfrm>
           <a:prstGeom prst="rect">
             <a:avLst/>
@@ -7868,333 +6469,18 @@
           </a:fontRef>
         </p:style>
         <p:txBody>
-          <a:bodyPr rtlCol="0" anchor="t" wrap="square" lIns="0" rIns="0" tIns="0" bIns="0"/>
+          <a:bodyPr rtlCol="0" anchor="ctr" wrap="square" lIns="0" rIns="0" tIns="0" bIns="0"/>
           <a:lstStyle/>
           <a:p>
             <a:pPr algn="l"/>
             <a:r>
-              <a:rPr sz="2800" b="1">
-                <a:solidFill>
-                  <a:srgbClr val="1B2A41"/>
-                </a:solidFill>
-                <a:latin typeface="Cambria"/>
-              </a:rPr>
-              <a:t>Какую отрасль кризис 1900–1902 годов поразил первой?</a:t>
-            </a:r>
-          </a:p>
-        </p:txBody>
-      </p:sp>
-      <p:sp>
-        <p:nvSpPr>
-          <p:cNvPr id="4" name="Rounded Rectangle 3"/>
-          <p:cNvSpPr/>
-          <p:nvPr/>
-        </p:nvSpPr>
-        <p:spPr>
-          <a:xfrm>
-            <a:off x="731520" y="2250000"/>
-            <a:ext cx="10698480" cy="1050000"/>
-          </a:xfrm>
-          <a:prstGeom prst="roundRect">
-            <a:avLst>
-              <a:gd name="adj" fmla="val 12000"/>
-            </a:avLst>
-          </a:prstGeom>
-          <a:solidFill>
-            <a:srgbClr val="F4EFE7"/>
-          </a:solidFill>
-          <a:ln>
-            <a:solidFill>
-              <a:srgbClr val="F4EFE7"/>
-            </a:solidFill>
-          </a:ln>
-          <a:effectLst/>
-        </p:spPr>
-        <p:style>
-          <a:lnRef idx="1">
-            <a:schemeClr val="accent1"/>
-          </a:lnRef>
-          <a:fillRef idx="3">
-            <a:schemeClr val="accent1"/>
-          </a:fillRef>
-          <a:effectRef idx="2">
-            <a:schemeClr val="accent1"/>
-          </a:effectRef>
-          <a:fontRef idx="minor">
-            <a:schemeClr val="lt1"/>
-          </a:fontRef>
-        </p:style>
-        <p:txBody>
-          <a:bodyPr rtlCol="0" anchor="ctr" wrap="square" lIns="228600" rIns="228600" tIns="228600" bIns="228600"/>
-          <a:lstStyle/>
-          <a:p>
-            <a:pPr algn="l"/>
-            <a:r>
-              <a:rPr sz="2200" b="1">
-                <a:solidFill>
-                  <a:srgbClr val="A8432F"/>
+              <a:rPr sz="2000" b="0">
+                <a:solidFill>
+                  <a:srgbClr val="C9D1DC"/>
                 </a:solidFill>
                 <a:latin typeface="Calibri"/>
               </a:rPr>
-              <a:t>А   </a:t>
-            </a:r>
-            <a:r>
-              <a:rPr sz="2200" b="0">
-                <a:solidFill>
-                  <a:srgbClr val="1B2A41"/>
-                </a:solidFill>
-                <a:latin typeface="Calibri"/>
-              </a:rPr>
-              <a:t>Швейную промышленность</a:t>
-            </a:r>
-          </a:p>
-        </p:txBody>
-      </p:sp>
-      <p:sp>
-        <p:nvSpPr>
-          <p:cNvPr id="5" name="Rounded Rectangle 4"/>
-          <p:cNvSpPr/>
-          <p:nvPr/>
-        </p:nvSpPr>
-        <p:spPr>
-          <a:xfrm>
-            <a:off x="731520" y="3470000"/>
-            <a:ext cx="10698480" cy="1050000"/>
-          </a:xfrm>
-          <a:prstGeom prst="roundRect">
-            <a:avLst>
-              <a:gd name="adj" fmla="val 12000"/>
-            </a:avLst>
-          </a:prstGeom>
-          <a:solidFill>
-            <a:srgbClr val="F4EFE7"/>
-          </a:solidFill>
-          <a:ln>
-            <a:solidFill>
-              <a:srgbClr val="F4EFE7"/>
-            </a:solidFill>
-          </a:ln>
-          <a:effectLst/>
-        </p:spPr>
-        <p:style>
-          <a:lnRef idx="1">
-            <a:schemeClr val="accent1"/>
-          </a:lnRef>
-          <a:fillRef idx="3">
-            <a:schemeClr val="accent1"/>
-          </a:fillRef>
-          <a:effectRef idx="2">
-            <a:schemeClr val="accent1"/>
-          </a:effectRef>
-          <a:fontRef idx="minor">
-            <a:schemeClr val="lt1"/>
-          </a:fontRef>
-        </p:style>
-        <p:txBody>
-          <a:bodyPr rtlCol="0" anchor="ctr" wrap="square" lIns="228600" rIns="228600" tIns="228600" bIns="228600"/>
-          <a:lstStyle/>
-          <a:p>
-            <a:pPr algn="l"/>
-            <a:r>
-              <a:rPr sz="2200" b="1">
-                <a:solidFill>
-                  <a:srgbClr val="A8432F"/>
-                </a:solidFill>
-                <a:latin typeface="Calibri"/>
-              </a:rPr>
-              <a:t>Б   </a:t>
-            </a:r>
-            <a:r>
-              <a:rPr sz="2200" b="0">
-                <a:solidFill>
-                  <a:srgbClr val="1B2A41"/>
-                </a:solidFill>
-                <a:latin typeface="Calibri"/>
-              </a:rPr>
-              <a:t>Металлургическую промышленность</a:t>
-            </a:r>
-          </a:p>
-        </p:txBody>
-      </p:sp>
-      <p:sp>
-        <p:nvSpPr>
-          <p:cNvPr id="6" name="answer"/>
-          <p:cNvSpPr/>
-          <p:nvPr/>
-        </p:nvSpPr>
-        <p:spPr>
-          <a:xfrm>
-            <a:off x="731520" y="3470000"/>
-            <a:ext cx="10698480" cy="1050000"/>
-          </a:xfrm>
-          <a:prstGeom prst="roundRect">
-            <a:avLst>
-              <a:gd name="adj" fmla="val 12000"/>
-            </a:avLst>
-          </a:prstGeom>
-          <a:solidFill>
-            <a:srgbClr val="A8432F"/>
-          </a:solidFill>
-          <a:ln>
-            <a:solidFill>
-              <a:srgbClr val="A8432F"/>
-            </a:solidFill>
-          </a:ln>
-          <a:effectLst/>
-        </p:spPr>
-        <p:style>
-          <a:lnRef idx="1">
-            <a:schemeClr val="accent1"/>
-          </a:lnRef>
-          <a:fillRef idx="3">
-            <a:schemeClr val="accent1"/>
-          </a:fillRef>
-          <a:effectRef idx="2">
-            <a:schemeClr val="accent1"/>
-          </a:effectRef>
-          <a:fontRef idx="minor">
-            <a:schemeClr val="lt1"/>
-          </a:fontRef>
-        </p:style>
-        <p:txBody>
-          <a:bodyPr rtlCol="0" anchor="ctr" wrap="square" lIns="228600" rIns="228600" tIns="228600" bIns="228600"/>
-          <a:lstStyle/>
-          <a:p>
-            <a:pPr algn="l"/>
-            <a:r>
-              <a:rPr sz="2200" b="1">
-                <a:solidFill>
-                  <a:srgbClr val="D9A441"/>
-                </a:solidFill>
-                <a:latin typeface="Calibri"/>
-              </a:rPr>
-              <a:t>✓  Б   </a:t>
-            </a:r>
-            <a:r>
-              <a:rPr sz="2200" b="1">
-                <a:solidFill>
-                  <a:srgbClr val="FFFFFF"/>
-                </a:solidFill>
-                <a:latin typeface="Calibri"/>
-              </a:rPr>
-              <a:t>Металлургическую промышленность</a:t>
-            </a:r>
-          </a:p>
-        </p:txBody>
-      </p:sp>
-      <p:sp>
-        <p:nvSpPr>
-          <p:cNvPr id="7" name="Rounded Rectangle 6"/>
-          <p:cNvSpPr/>
-          <p:nvPr/>
-        </p:nvSpPr>
-        <p:spPr>
-          <a:xfrm>
-            <a:off x="731520" y="4690000"/>
-            <a:ext cx="10698480" cy="1050000"/>
-          </a:xfrm>
-          <a:prstGeom prst="roundRect">
-            <a:avLst>
-              <a:gd name="adj" fmla="val 12000"/>
-            </a:avLst>
-          </a:prstGeom>
-          <a:solidFill>
-            <a:srgbClr val="F4EFE7"/>
-          </a:solidFill>
-          <a:ln>
-            <a:solidFill>
-              <a:srgbClr val="F4EFE7"/>
-            </a:solidFill>
-          </a:ln>
-          <a:effectLst/>
-        </p:spPr>
-        <p:style>
-          <a:lnRef idx="1">
-            <a:schemeClr val="accent1"/>
-          </a:lnRef>
-          <a:fillRef idx="3">
-            <a:schemeClr val="accent1"/>
-          </a:fillRef>
-          <a:effectRef idx="2">
-            <a:schemeClr val="accent1"/>
-          </a:effectRef>
-          <a:fontRef idx="minor">
-            <a:schemeClr val="lt1"/>
-          </a:fontRef>
-        </p:style>
-        <p:txBody>
-          <a:bodyPr rtlCol="0" anchor="ctr" wrap="square" lIns="228600" rIns="228600" tIns="228600" bIns="228600"/>
-          <a:lstStyle/>
-          <a:p>
-            <a:pPr algn="l"/>
-            <a:r>
-              <a:rPr sz="2200" b="1">
-                <a:solidFill>
-                  <a:srgbClr val="A8432F"/>
-                </a:solidFill>
-                <a:latin typeface="Calibri"/>
-              </a:rPr>
-              <a:t>В   </a:t>
-            </a:r>
-            <a:r>
-              <a:rPr sz="2200" b="0">
-                <a:solidFill>
-                  <a:srgbClr val="1B2A41"/>
-                </a:solidFill>
-                <a:latin typeface="Calibri"/>
-              </a:rPr>
-              <a:t>Химическую промышленность</a:t>
-            </a:r>
-          </a:p>
-        </p:txBody>
-      </p:sp>
-      <p:sp>
-        <p:nvSpPr>
-          <p:cNvPr id="8" name="Rectangle 7"/>
-          <p:cNvSpPr/>
-          <p:nvPr/>
-        </p:nvSpPr>
-        <p:spPr>
-          <a:xfrm>
-            <a:off x="731520" y="6400000"/>
-            <a:ext cx="10698480" cy="274320"/>
-          </a:xfrm>
-          <a:prstGeom prst="rect">
-            <a:avLst/>
-          </a:prstGeom>
-          <a:noFill/>
-          <a:ln>
-            <a:noFill/>
-          </a:ln>
-          <a:effectLst/>
-        </p:spPr>
-        <p:style>
-          <a:lnRef idx="1">
-            <a:schemeClr val="accent1"/>
-          </a:lnRef>
-          <a:fillRef idx="3">
-            <a:schemeClr val="accent1"/>
-          </a:fillRef>
-          <a:effectRef idx="2">
-            <a:schemeClr val="accent1"/>
-          </a:effectRef>
-          <a:fontRef idx="minor">
-            <a:schemeClr val="lt1"/>
-          </a:fontRef>
-        </p:style>
-        <p:txBody>
-          <a:bodyPr rtlCol="0" anchor="ctr" wrap="square" lIns="0" rIns="0" tIns="0" bIns="0"/>
-          <a:lstStyle/>
-          <a:p>
-            <a:pPr algn="l"/>
-            <a:r>
-              <a:rPr sz="1100" b="0">
-                <a:solidFill>
-                  <a:srgbClr val="6B7686"/>
-                </a:solidFill>
-                <a:latin typeface="Calibri"/>
-              </a:rPr>
-              <a:t>Нажмите — правильный ответ подсветится</a:t>
+              <a:t>Тема пройдена: экономические кризисы XIX–XX веков</a:t>
             </a:r>
           </a:p>
         </p:txBody>
@@ -8204,92 +6490,6 @@
   <p:clrMapOvr>
     <a:masterClrMapping/>
   </p:clrMapOvr>
-  <p:timing>
-    <p:tnLst>
-      <p:par>
-        <p:cTn id="1" dur="indefinite" restart="never" nodeType="tmRoot">
-          <p:childTnLst>
-            <p:seq concurrent="1" nextAc="seek">
-              <p:cTn id="2" dur="indefinite" nodeType="mainSeq">
-                <p:childTnLst>
-                  <p:par>
-                    <p:cTn id="3" fill="hold">
-                      <p:stCondLst>
-                        <p:cond delay="indefinite"/>
-                      </p:stCondLst>
-                      <p:childTnLst>
-                        <p:par>
-                          <p:cTn id="4" fill="hold">
-                            <p:stCondLst>
-                              <p:cond delay="0"/>
-                            </p:stCondLst>
-                            <p:childTnLst>
-                              <p:par>
-                                <p:cTn id="5" presetID="10" presetClass="entr" presetSubtype="0" fill="hold" grpId="0" nodeType="clickEffect">
-                                  <p:stCondLst>
-                                    <p:cond delay="0"/>
-                                  </p:stCondLst>
-                                  <p:childTnLst>
-                                    <p:set>
-                                      <p:cBhvr>
-                                        <p:cTn id="6" dur="1" fill="hold">
-                                          <p:stCondLst>
-                                            <p:cond delay="0"/>
-                                          </p:stCondLst>
-                                        </p:cTn>
-                                        <p:tgtEl>
-                                          <p:spTgt spid="6"/>
-                                        </p:tgtEl>
-                                        <p:attrNameLst>
-                                          <p:attrName>style.visibility</p:attrName>
-                                        </p:attrNameLst>
-                                      </p:cBhvr>
-                                      <p:to>
-                                        <p:strVal val="visible"/>
-                                      </p:to>
-                                    </p:set>
-                                    <p:animEffect transition="in" filter="fade">
-                                      <p:cBhvr>
-                                        <p:cTn id="7" dur="500"/>
-                                        <p:tgtEl>
-                                          <p:spTgt spid="6"/>
-                                        </p:tgtEl>
-                                      </p:cBhvr>
-                                    </p:animEffect>
-                                  </p:childTnLst>
-                                </p:cTn>
-                              </p:par>
-                            </p:childTnLst>
-                          </p:cTn>
-                        </p:par>
-                      </p:childTnLst>
-                    </p:cTn>
-                  </p:par>
-                </p:childTnLst>
-              </p:cTn>
-              <p:prevCondLst>
-                <p:cond evt="onPrev" delay="0">
-                  <p:tgtEl>
-                    <p:sldTgt/>
-                  </p:tgtEl>
-                </p:cond>
-              </p:prevCondLst>
-              <p:nextCondLst>
-                <p:cond evt="onNext" delay="0">
-                  <p:tgtEl>
-                    <p:sldTgt/>
-                  </p:tgtEl>
-                </p:cond>
-              </p:nextCondLst>
-            </p:seq>
-          </p:childTnLst>
-        </p:cTn>
-      </p:par>
-    </p:tnLst>
-    <p:bldLst>
-      <p:bldP spid="6" grpId="0" animBg="1"/>
-    </p:bldLst>
-  </p:timing>
 </p:sld>
 </file>
 

</xml_diff>